<commit_message>
AI helper runs on free models: Chrome on-device AI, local Ollama, or any OpenAI-compatible free tier
- lib/assist/browser.ts: Chrome Prompt API (Gemini Nano), no key, nothing leaves the device
- model.ts: provider switch (ollama, openai-compatible, anthropic); Ollama reachability check
- AI never rewords eligibility: 'who can get it' shows official text only, API refuses it
- Guard now rejects uncited sentences, repetition and more than five sentences
- docs/llm-rag.md: live results from free 1B/3B models and what they changed
- README, FEEDBACK.md and deck updated; commit reference corrected to 187b71c
</commit_message>
<xml_diff>
--- a/docs/Welfare-Navigator-PS07.pptx
+++ b/docs/Welfare-Navigator-PS07.pptx
@@ -3153,7 +3153,7 @@
                 <a:ea typeface="Arial" pitchFamily="34" charset="-122"/>
                 <a:cs typeface="Arial" pitchFamily="34" charset="-120"/>
               </a:rPr>
-              <a:t>Answers never reach our server. Only voice and the AI rewrite need internet.</a:t>
+              <a:t>Answers never reach our server. Only voice and hosted AI need internet.</a:t>
             </a:r>
             <a:endParaRPr lang="en-US" sz="1300" dirty="0"/>
           </a:p>
@@ -4087,7 +4087,7 @@
                 <a:ea typeface="Arial" pitchFamily="34" charset="-122"/>
                 <a:cs typeface="Arial" pitchFamily="34" charset="-120"/>
               </a:rPr>
-              <a:t>per scheme question</a:t>
+              <a:t>+ Chrome on-device AI</a:t>
             </a:r>
             <a:endParaRPr lang="en-US" sz="950" dirty="0"/>
           </a:p>
@@ -4486,7 +4486,7 @@
                 <a:ea typeface="Arial" pitchFamily="34" charset="-122"/>
                 <a:cs typeface="Arial" pitchFamily="34" charset="-120"/>
               </a:rPr>
-              <a:t>Model API</a:t>
+              <a:t>Free model</a:t>
             </a:r>
             <a:endParaRPr lang="en-US" sz="950" dirty="0"/>
           </a:p>
@@ -4503,7 +4503,7 @@
                 <a:ea typeface="Arial" pitchFamily="34" charset="-122"/>
                 <a:cs typeface="Arial" pitchFamily="34" charset="-120"/>
               </a:rPr>
-              <a:t>only if key is set</a:t>
+              <a:t>Ollama · free tier</a:t>
             </a:r>
             <a:endParaRPr lang="en-US" sz="950" dirty="0"/>
           </a:p>
@@ -10191,12 +10191,12 @@
           <a:p>
             <a:pPr indent="0" marL="0">
               <a:spcAft>
-                <a:spcPts val="600"/>
+                <a:spcPts val="500"/>
               </a:spcAft>
               <a:buNone/>
             </a:pPr>
             <a:r>
-              <a:rPr lang="en-US" sz="1200" b="1" dirty="0">
+              <a:rPr lang="en-US" sz="1150" b="1" dirty="0">
                 <a:solidFill>
                   <a:srgbClr val="E4A11B"/>
                 </a:solidFill>
@@ -10208,12 +10208,12 @@
             </a:r>
             <a:pPr indent="0" marL="0">
               <a:spcAft>
-                <a:spcPts val="600"/>
+                <a:spcPts val="500"/>
               </a:spcAft>
               <a:buNone/>
             </a:pPr>
             <a:r>
-              <a:rPr lang="en-US" sz="1200" dirty="0">
+              <a:rPr lang="en-US" sz="1150" dirty="0">
                 <a:solidFill>
                   <a:srgbClr val="D5E3DB"/>
                 </a:solidFill>
@@ -10221,19 +10221,19 @@
                 <a:ea typeface="Arial" pitchFamily="34" charset="-122"/>
                 <a:cs typeface="Arial" pitchFamily="34" charset="-120"/>
               </a:rPr>
-              <a:t>coding, review, tests, docs; optional runtime model for the plain-language helper</a:t>
-            </a:r>
-            <a:endParaRPr lang="en-US" sz="1200" dirty="0"/>
+              <a:t>coding, review, tests, docs</a:t>
+            </a:r>
+            <a:endParaRPr lang="en-US" sz="1150" dirty="0"/>
           </a:p>
           <a:p>
             <a:pPr indent="0" marL="0">
               <a:spcAft>
-                <a:spcPts val="600"/>
+                <a:spcPts val="500"/>
               </a:spcAft>
               <a:buNone/>
             </a:pPr>
             <a:r>
-              <a:rPr lang="en-US" sz="1200" b="1" dirty="0">
+              <a:rPr lang="en-US" sz="1150" b="1" dirty="0">
                 <a:solidFill>
                   <a:srgbClr val="E4A11B"/>
                 </a:solidFill>
@@ -10245,12 +10245,12 @@
             </a:r>
             <a:pPr indent="0" marL="0">
               <a:spcAft>
-                <a:spcPts val="600"/>
+                <a:spcPts val="500"/>
               </a:spcAft>
               <a:buNone/>
             </a:pPr>
             <a:r>
-              <a:rPr lang="en-US" sz="1200" dirty="0">
+              <a:rPr lang="en-US" sz="1150" dirty="0">
                 <a:solidFill>
                   <a:srgbClr val="D5E3DB"/>
                 </a:solidFill>
@@ -10258,19 +10258,19 @@
                 <a:ea typeface="Arial" pitchFamily="34" charset="-122"/>
                 <a:cs typeface="Arial" pitchFamily="34" charset="-120"/>
               </a:rPr>
-              <a:t>coding, Malayalam and English text drafts, source cross-checks</a:t>
-            </a:r>
-            <a:endParaRPr lang="en-US" sz="1200" dirty="0"/>
+              <a:t>coding, Malayalam and English drafts, source cross-checks</a:t>
+            </a:r>
+            <a:endParaRPr lang="en-US" sz="1150" dirty="0"/>
           </a:p>
           <a:p>
             <a:pPr indent="0" marL="0">
               <a:spcAft>
-                <a:spcPts val="600"/>
+                <a:spcPts val="500"/>
               </a:spcAft>
               <a:buNone/>
             </a:pPr>
             <a:r>
-              <a:rPr lang="en-US" sz="1200" b="1" dirty="0">
+              <a:rPr lang="en-US" sz="1150" b="1" dirty="0">
                 <a:solidFill>
                   <a:srgbClr val="E4A11B"/>
                 </a:solidFill>
@@ -10282,12 +10282,12 @@
             </a:r>
             <a:pPr indent="0" marL="0">
               <a:spcAft>
-                <a:spcPts val="600"/>
+                <a:spcPts val="500"/>
               </a:spcAft>
               <a:buNone/>
             </a:pPr>
             <a:r>
-              <a:rPr lang="en-US" sz="1200" dirty="0">
+              <a:rPr lang="en-US" sz="1150" dirty="0">
                 <a:solidFill>
                   <a:srgbClr val="D5E3DB"/>
                 </a:solidFill>
@@ -10295,16 +10295,16 @@
                 <a:ea typeface="Arial" pitchFamily="34" charset="-122"/>
                 <a:cs typeface="Arial" pitchFamily="34" charset="-120"/>
               </a:rPr>
-              <a:t>recorded question clips   </a:t>
+              <a:t>question audio   </a:t>
             </a:r>
             <a:pPr indent="0" marL="0">
               <a:spcAft>
-                <a:spcPts val="600"/>
+                <a:spcPts val="500"/>
               </a:spcAft>
               <a:buNone/>
             </a:pPr>
             <a:r>
-              <a:rPr lang="en-US" sz="1200" b="1" dirty="0">
+              <a:rPr lang="en-US" sz="1150" b="1" dirty="0">
                 <a:solidFill>
                   <a:srgbClr val="E4A11B"/>
                 </a:solidFill>
@@ -10316,12 +10316,12 @@
             </a:r>
             <a:pPr indent="0" marL="0">
               <a:spcAft>
-                <a:spcPts val="600"/>
+                <a:spcPts val="500"/>
               </a:spcAft>
               <a:buNone/>
             </a:pPr>
             <a:r>
-              <a:rPr lang="en-US" sz="1200" dirty="0">
+              <a:rPr lang="en-US" sz="1150" dirty="0">
                 <a:solidFill>
                   <a:srgbClr val="D5E3DB"/>
                 </a:solidFill>
@@ -10331,17 +10331,54 @@
               </a:rPr>
               <a:t>optional voice</a:t>
             </a:r>
-            <a:endParaRPr lang="en-US" sz="1200" dirty="0"/>
+            <a:endParaRPr lang="en-US" sz="1150" dirty="0"/>
           </a:p>
           <a:p>
             <a:pPr indent="0" marL="0">
               <a:spcAft>
-                <a:spcPts val="600"/>
+                <a:spcPts val="500"/>
               </a:spcAft>
               <a:buNone/>
             </a:pPr>
             <a:r>
-              <a:rPr lang="en-US" sz="1200" b="1" dirty="0">
+              <a:rPr lang="en-US" sz="1150" b="1" dirty="0">
+                <a:solidFill>
+                  <a:srgbClr val="E4A11B"/>
+                </a:solidFill>
+                <a:latin typeface="Arial" pitchFamily="34" charset="0"/>
+                <a:ea typeface="Arial" pitchFamily="34" charset="-122"/>
+                <a:cs typeface="Arial" pitchFamily="34" charset="-120"/>
+              </a:rPr>
+              <a:t>Runtime helper  </a:t>
+            </a:r>
+            <a:pPr indent="0" marL="0">
+              <a:spcAft>
+                <a:spcPts val="500"/>
+              </a:spcAft>
+              <a:buNone/>
+            </a:pPr>
+            <a:r>
+              <a:rPr lang="en-US" sz="1150" dirty="0">
+                <a:solidFill>
+                  <a:srgbClr val="D5E3DB"/>
+                </a:solidFill>
+                <a:latin typeface="Arial" pitchFamily="34" charset="0"/>
+                <a:ea typeface="Arial" pitchFamily="34" charset="-122"/>
+                <a:cs typeface="Arial" pitchFamily="34" charset="-120"/>
+              </a:rPr>
+              <a:t>Chrome on-device AI or Ollama gemma3:4b; free, no key</a:t>
+            </a:r>
+            <a:endParaRPr lang="en-US" sz="1150" dirty="0"/>
+          </a:p>
+          <a:p>
+            <a:pPr indent="0" marL="0">
+              <a:spcAft>
+                <a:spcPts val="500"/>
+              </a:spcAft>
+              <a:buNone/>
+            </a:pPr>
+            <a:r>
+              <a:rPr lang="en-US" sz="1150" b="1" dirty="0">
                 <a:solidFill>
                   <a:srgbClr val="FFFFFF"/>
                 </a:solidFill>
@@ -10349,9 +10386,9 @@
                 <a:ea typeface="Arial" pitchFamily="34" charset="-122"/>
                 <a:cs typeface="Arial" pitchFamily="34" charset="-120"/>
               </a:rPr>
-              <a:t>No AI decides eligibility, writes rules, or sees a family's answers.</a:t>
-            </a:r>
-            <a:endParaRPr lang="en-US" sz="1200" dirty="0"/>
+              <a:t>No AI decides or rewords eligibility, or sees a family's answers.</a:t>
+            </a:r>
+            <a:endParaRPr lang="en-US" sz="1150" dirty="0"/>
           </a:p>
         </p:txBody>
       </p:sp>
@@ -10493,12 +10530,12 @@
           <a:p>
             <a:pPr indent="0" marL="0">
               <a:spcAft>
-                <a:spcPts val="600"/>
+                <a:spcPts val="500"/>
               </a:spcAft>
               <a:buNone/>
             </a:pPr>
             <a:r>
-              <a:rPr lang="en-US" sz="1200" b="1" dirty="0">
+              <a:rPr lang="en-US" sz="1150" b="1" dirty="0">
                 <a:solidFill>
                   <a:srgbClr val="E4A11B"/>
                 </a:solidFill>
@@ -10510,12 +10547,12 @@
             </a:r>
             <a:pPr indent="0" marL="0">
               <a:spcAft>
-                <a:spcPts val="600"/>
+                <a:spcPts val="500"/>
               </a:spcAft>
               <a:buNone/>
             </a:pPr>
             <a:r>
-              <a:rPr lang="en-US" sz="1200" b="1" dirty="0">
+              <a:rPr lang="en-US" sz="1150" b="1" dirty="0">
                 <a:solidFill>
                   <a:srgbClr val="FFFFFF"/>
                 </a:solidFill>
@@ -10525,17 +10562,17 @@
               </a:rPr>
               <a:t>“Add an AI component.”</a:t>
             </a:r>
-            <a:endParaRPr lang="en-US" sz="1200" dirty="0"/>
+            <a:endParaRPr lang="en-US" sz="1150" dirty="0"/>
           </a:p>
           <a:p>
             <a:pPr indent="0" marL="0">
               <a:spcAft>
-                <a:spcPts val="600"/>
+                <a:spcPts val="500"/>
               </a:spcAft>
               <a:buNone/>
             </a:pPr>
             <a:r>
-              <a:rPr lang="en-US" sz="1200" dirty="0">
+              <a:rPr lang="en-US" sz="1150" dirty="0">
                 <a:solidFill>
                   <a:srgbClr val="D5E3DB"/>
                 </a:solidFill>
@@ -10543,19 +10580,19 @@
                 <a:ea typeface="Arial" pitchFamily="34" charset="-122"/>
                 <a:cs typeface="Arial" pitchFamily="34" charset="-120"/>
               </a:rPr>
-              <a:t>A plain-language helper grounded in official quotes: every sentence cited, any number not in the source rejected, no answers sent. Plus an automated rule audit in CI. Commit ba4e8d9.</a:t>
-            </a:r>
-            <a:endParaRPr lang="en-US" sz="1200" dirty="0"/>
+              <a:t>A plain-language helper grounded in official quotes, running free on-device or on a local model, plus an AI-assisted rule audit in CI.</a:t>
+            </a:r>
+            <a:endParaRPr lang="en-US" sz="1150" dirty="0"/>
           </a:p>
           <a:p>
             <a:pPr indent="0" marL="0">
               <a:spcAft>
-                <a:spcPts val="600"/>
+                <a:spcPts val="500"/>
               </a:spcAft>
               <a:buNone/>
             </a:pPr>
             <a:r>
-              <a:rPr lang="en-US" sz="1200" b="1" dirty="0">
+              <a:rPr lang="en-US" sz="1150" b="1" dirty="0">
                 <a:solidFill>
                   <a:srgbClr val="E4A11B"/>
                 </a:solidFill>
@@ -10563,16 +10600,16 @@
                 <a:ea typeface="Arial" pitchFamily="34" charset="-122"/>
                 <a:cs typeface="Arial" pitchFamily="34" charset="-120"/>
               </a:rPr>
-              <a:t>Pre-coding review  </a:t>
+              <a:t>What testing taught us  </a:t>
             </a:r>
             <a:pPr indent="0" marL="0">
               <a:spcAft>
-                <a:spcPts val="600"/>
+                <a:spcPts val="500"/>
               </a:spcAft>
               <a:buNone/>
             </a:pPr>
             <a:r>
-              <a:rPr lang="en-US" sz="1200" dirty="0">
+              <a:rPr lang="en-US" sz="1150" dirty="0">
                 <a:solidFill>
                   <a:srgbClr val="D5E3DB"/>
                 </a:solidFill>
@@ -10580,9 +10617,29 @@
                 <a:ea typeface="Arial" pitchFamily="34" charset="-122"/>
                 <a:cs typeface="Arial" pitchFamily="34" charset="-120"/>
               </a:rPr>
-              <a:t>rule trees, unknown ≠ rejection, income bands, multi-select livelihood, offline build, reviewer runner. Log in FEEDBACK.md.</a:t>
-            </a:r>
-            <a:endParaRPr lang="en-US" sz="1200" dirty="0"/>
+              <a:t>free 1–3B models: guard rejected 3 of 4 bad answers; one misread eligibility, so AI is now barred from eligibility.</a:t>
+            </a:r>
+            <a:endParaRPr lang="en-US" sz="1150" dirty="0"/>
+          </a:p>
+          <a:p>
+            <a:pPr indent="0" marL="0">
+              <a:spcAft>
+                <a:spcPts val="500"/>
+              </a:spcAft>
+              <a:buNone/>
+            </a:pPr>
+            <a:r>
+              <a:rPr lang="en-US" sz="1150" dirty="0">
+                <a:solidFill>
+                  <a:srgbClr val="D5E3DB"/>
+                </a:solidFill>
+                <a:latin typeface="Arial" pitchFamily="34" charset="0"/>
+                <a:ea typeface="Arial" pitchFamily="34" charset="-122"/>
+                <a:cs typeface="Arial" pitchFamily="34" charset="-120"/>
+              </a:rPr>
+              <a:t>Full log in FEEDBACK.md · commit 187b71c</a:t>
+            </a:r>
+            <a:endParaRPr lang="en-US" sz="1150" dirty="0"/>
           </a:p>
         </p:txBody>
       </p:sp>

</xml_diff>